<commit_message>
fix(ai): add connection check caching, automatic model fallback, and graceful rate-limit handling
</commit_message>
<xml_diff>
--- a/eWitnessVault_Gemma_Hackafest_Pitch.pptx
+++ b/eWitnessVault_Gemma_Hackafest_Pitch.pptx
@@ -5,20 +5,20 @@
     <p:sldMasterId id="2147483648" r:id="rId1"/>
   </p:sldMasterIdLst>
   <p:sldIdLst>
-    <p:sldId id="256" r:id="rId7"/>
-    <p:sldId id="257" r:id="rId8"/>
-    <p:sldId id="258" r:id="rId9"/>
-    <p:sldId id="259" r:id="rId10"/>
-    <p:sldId id="260" r:id="rId11"/>
-    <p:sldId id="261" r:id="rId12"/>
-    <p:sldId id="262" r:id="rId13"/>
-    <p:sldId id="263" r:id="rId14"/>
-    <p:sldId id="264" r:id="rId15"/>
-    <p:sldId id="265" r:id="rId16"/>
-    <p:sldId id="266" r:id="rId17"/>
-    <p:sldId id="267" r:id="rId18"/>
+    <p:sldId id="256" r:id="rId2"/>
+    <p:sldId id="257" r:id="rId3"/>
+    <p:sldId id="258" r:id="rId4"/>
+    <p:sldId id="259" r:id="rId5"/>
+    <p:sldId id="260" r:id="rId6"/>
+    <p:sldId id="261" r:id="rId7"/>
+    <p:sldId id="262" r:id="rId8"/>
+    <p:sldId id="263" r:id="rId9"/>
+    <p:sldId id="264" r:id="rId10"/>
+    <p:sldId id="265" r:id="rId11"/>
+    <p:sldId id="266" r:id="rId12"/>
+    <p:sldId id="267" r:id="rId13"/>
   </p:sldIdLst>
-  <p:sldSz cx="12191695" cy="6858000" type="screen4x3"/>
+  <p:sldSz cx="12192000" cy="6858000"/>
   <p:notesSz cx="6858000" cy="9144000"/>
   <p:defaultTextStyle>
     <a:defPPr>
@@ -115,6 +115,22 @@
       </a:defRPr>
     </a:lvl9pPr>
   </p:defaultTextStyle>
+  <p:extLst>
+    <p:ext uri="{EFAFB233-063F-42B5-8137-9DF3F51BA10A}">
+      <p15:sldGuideLst xmlns:p15="http://schemas.microsoft.com/office/powerpoint/2012/main">
+        <p15:guide id="1" orient="horz" pos="2160">
+          <p15:clr>
+            <a:srgbClr val="A4A3A4"/>
+          </p15:clr>
+        </p15:guide>
+        <p15:guide id="2" pos="2880">
+          <p15:clr>
+            <a:srgbClr val="A4A3A4"/>
+          </p15:clr>
+        </p15:guide>
+      </p15:sldGuideLst>
+    </p:ext>
+  </p:extLst>
 </p:presentation>
 </file>
 
@@ -156,10 +172,9 @@
           <a:lstStyle/>
           <a:p>
             <a:r>
-              <a:rPr lang="en-US" smtClean="0"/>
+              <a:rPr lang="en-US"/>
               <a:t>Click to edit Master title style</a:t>
             </a:r>
-            <a:endParaRPr lang="en-US"/>
           </a:p>
         </p:txBody>
       </p:sp>
@@ -275,10 +290,9 @@
           </a:lstStyle>
           <a:p>
             <a:r>
-              <a:rPr lang="en-US" smtClean="0"/>
+              <a:rPr lang="en-US"/>
               <a:t>Click to edit Master subtitle style</a:t>
             </a:r>
-            <a:endParaRPr lang="en-US"/>
           </a:p>
         </p:txBody>
       </p:sp>
@@ -299,7 +313,7 @@
           <a:p>
             <a:fld id="{5BCAD085-E8A6-8845-BD4E-CB4CCA059FC4}" type="datetimeFigureOut">
               <a:rPr lang="en-US" smtClean="0"/>
-              <a:t>1/27/13</a:t>
+              <a:t>10/16/2026</a:t>
             </a:fld>
             <a:endParaRPr lang="en-US"/>
           </a:p>
@@ -393,10 +407,9 @@
           <a:lstStyle/>
           <a:p>
             <a:r>
-              <a:rPr lang="en-US" smtClean="0"/>
+              <a:rPr lang="en-US"/>
               <a:t>Click to edit Master title style</a:t>
             </a:r>
-            <a:endParaRPr lang="en-US"/>
           </a:p>
         </p:txBody>
       </p:sp>
@@ -417,38 +430,37 @@
           <a:p>
             <a:pPr lvl="0"/>
             <a:r>
-              <a:rPr lang="en-US" smtClean="0"/>
+              <a:rPr lang="en-US"/>
               <a:t>Click to edit Master text styles</a:t>
             </a:r>
           </a:p>
           <a:p>
             <a:pPr lvl="1"/>
             <a:r>
-              <a:rPr lang="en-US" smtClean="0"/>
+              <a:rPr lang="en-US"/>
               <a:t>Second level</a:t>
             </a:r>
           </a:p>
           <a:p>
             <a:pPr lvl="2"/>
             <a:r>
-              <a:rPr lang="en-US" smtClean="0"/>
+              <a:rPr lang="en-US"/>
               <a:t>Third level</a:t>
             </a:r>
           </a:p>
           <a:p>
             <a:pPr lvl="3"/>
             <a:r>
-              <a:rPr lang="en-US" smtClean="0"/>
+              <a:rPr lang="en-US"/>
               <a:t>Fourth level</a:t>
             </a:r>
           </a:p>
           <a:p>
             <a:pPr lvl="4"/>
             <a:r>
-              <a:rPr lang="en-US" smtClean="0"/>
+              <a:rPr lang="en-US"/>
               <a:t>Fifth level</a:t>
             </a:r>
-            <a:endParaRPr lang="en-US"/>
           </a:p>
         </p:txBody>
       </p:sp>
@@ -469,7 +481,7 @@
           <a:p>
             <a:fld id="{5BCAD085-E8A6-8845-BD4E-CB4CCA059FC4}" type="datetimeFigureOut">
               <a:rPr lang="en-US" smtClean="0"/>
-              <a:t>1/27/13</a:t>
+              <a:t>10/16/2026</a:t>
             </a:fld>
             <a:endParaRPr lang="en-US"/>
           </a:p>
@@ -568,10 +580,9 @@
           <a:lstStyle/>
           <a:p>
             <a:r>
-              <a:rPr lang="en-US" smtClean="0"/>
+              <a:rPr lang="en-US"/>
               <a:t>Click to edit Master title style</a:t>
             </a:r>
-            <a:endParaRPr lang="en-US"/>
           </a:p>
         </p:txBody>
       </p:sp>
@@ -597,38 +608,37 @@
           <a:p>
             <a:pPr lvl="0"/>
             <a:r>
-              <a:rPr lang="en-US" smtClean="0"/>
+              <a:rPr lang="en-US"/>
               <a:t>Click to edit Master text styles</a:t>
             </a:r>
           </a:p>
           <a:p>
             <a:pPr lvl="1"/>
             <a:r>
-              <a:rPr lang="en-US" smtClean="0"/>
+              <a:rPr lang="en-US"/>
               <a:t>Second level</a:t>
             </a:r>
           </a:p>
           <a:p>
             <a:pPr lvl="2"/>
             <a:r>
-              <a:rPr lang="en-US" smtClean="0"/>
+              <a:rPr lang="en-US"/>
               <a:t>Third level</a:t>
             </a:r>
           </a:p>
           <a:p>
             <a:pPr lvl="3"/>
             <a:r>
-              <a:rPr lang="en-US" smtClean="0"/>
+              <a:rPr lang="en-US"/>
               <a:t>Fourth level</a:t>
             </a:r>
           </a:p>
           <a:p>
             <a:pPr lvl="4"/>
             <a:r>
-              <a:rPr lang="en-US" smtClean="0"/>
+              <a:rPr lang="en-US"/>
               <a:t>Fifth level</a:t>
             </a:r>
-            <a:endParaRPr lang="en-US"/>
           </a:p>
         </p:txBody>
       </p:sp>
@@ -649,7 +659,7 @@
           <a:p>
             <a:fld id="{5BCAD085-E8A6-8845-BD4E-CB4CCA059FC4}" type="datetimeFigureOut">
               <a:rPr lang="en-US" smtClean="0"/>
-              <a:t>1/27/13</a:t>
+              <a:t>10/16/2026</a:t>
             </a:fld>
             <a:endParaRPr lang="en-US"/>
           </a:p>
@@ -743,10 +753,9 @@
           <a:lstStyle/>
           <a:p>
             <a:r>
-              <a:rPr lang="en-US" smtClean="0"/>
+              <a:rPr lang="en-US"/>
               <a:t>Click to edit Master title style</a:t>
             </a:r>
-            <a:endParaRPr lang="en-US"/>
           </a:p>
         </p:txBody>
       </p:sp>
@@ -767,38 +776,37 @@
           <a:p>
             <a:pPr lvl="0"/>
             <a:r>
-              <a:rPr lang="en-US" smtClean="0"/>
+              <a:rPr lang="en-US"/>
               <a:t>Click to edit Master text styles</a:t>
             </a:r>
           </a:p>
           <a:p>
             <a:pPr lvl="1"/>
             <a:r>
-              <a:rPr lang="en-US" smtClean="0"/>
+              <a:rPr lang="en-US"/>
               <a:t>Second level</a:t>
             </a:r>
           </a:p>
           <a:p>
             <a:pPr lvl="2"/>
             <a:r>
-              <a:rPr lang="en-US" smtClean="0"/>
+              <a:rPr lang="en-US"/>
               <a:t>Third level</a:t>
             </a:r>
           </a:p>
           <a:p>
             <a:pPr lvl="3"/>
             <a:r>
-              <a:rPr lang="en-US" smtClean="0"/>
+              <a:rPr lang="en-US"/>
               <a:t>Fourth level</a:t>
             </a:r>
           </a:p>
           <a:p>
             <a:pPr lvl="4"/>
             <a:r>
-              <a:rPr lang="en-US" smtClean="0"/>
+              <a:rPr lang="en-US"/>
               <a:t>Fifth level</a:t>
             </a:r>
-            <a:endParaRPr lang="en-US"/>
           </a:p>
         </p:txBody>
       </p:sp>
@@ -819,7 +827,7 @@
           <a:p>
             <a:fld id="{5BCAD085-E8A6-8845-BD4E-CB4CCA059FC4}" type="datetimeFigureOut">
               <a:rPr lang="en-US" smtClean="0"/>
-              <a:t>1/27/13</a:t>
+              <a:t>10/16/2026</a:t>
             </a:fld>
             <a:endParaRPr lang="en-US"/>
           </a:p>
@@ -922,10 +930,9 @@
           </a:lstStyle>
           <a:p>
             <a:r>
-              <a:rPr lang="en-US" smtClean="0"/>
+              <a:rPr lang="en-US"/>
               <a:t>Click to edit Master title style</a:t>
             </a:r>
-            <a:endParaRPr lang="en-US"/>
           </a:p>
         </p:txBody>
       </p:sp>
@@ -1042,7 +1049,7 @@
           <a:p>
             <a:pPr lvl="0"/>
             <a:r>
-              <a:rPr lang="en-US" smtClean="0"/>
+              <a:rPr lang="en-US"/>
               <a:t>Click to edit Master text styles</a:t>
             </a:r>
           </a:p>
@@ -1065,7 +1072,7 @@
           <a:p>
             <a:fld id="{5BCAD085-E8A6-8845-BD4E-CB4CCA059FC4}" type="datetimeFigureOut">
               <a:rPr lang="en-US" smtClean="0"/>
-              <a:t>1/27/13</a:t>
+              <a:t>10/16/2026</a:t>
             </a:fld>
             <a:endParaRPr lang="en-US"/>
           </a:p>
@@ -1159,10 +1166,9 @@
           <a:lstStyle/>
           <a:p>
             <a:r>
-              <a:rPr lang="en-US" smtClean="0"/>
+              <a:rPr lang="en-US"/>
               <a:t>Click to edit Master title style</a:t>
             </a:r>
-            <a:endParaRPr lang="en-US"/>
           </a:p>
         </p:txBody>
       </p:sp>
@@ -1216,38 +1222,37 @@
           <a:p>
             <a:pPr lvl="0"/>
             <a:r>
-              <a:rPr lang="en-US" smtClean="0"/>
+              <a:rPr lang="en-US"/>
               <a:t>Click to edit Master text styles</a:t>
             </a:r>
           </a:p>
           <a:p>
             <a:pPr lvl="1"/>
             <a:r>
-              <a:rPr lang="en-US" smtClean="0"/>
+              <a:rPr lang="en-US"/>
               <a:t>Second level</a:t>
             </a:r>
           </a:p>
           <a:p>
             <a:pPr lvl="2"/>
             <a:r>
-              <a:rPr lang="en-US" smtClean="0"/>
+              <a:rPr lang="en-US"/>
               <a:t>Third level</a:t>
             </a:r>
           </a:p>
           <a:p>
             <a:pPr lvl="3"/>
             <a:r>
-              <a:rPr lang="en-US" smtClean="0"/>
+              <a:rPr lang="en-US"/>
               <a:t>Fourth level</a:t>
             </a:r>
           </a:p>
           <a:p>
             <a:pPr lvl="4"/>
             <a:r>
-              <a:rPr lang="en-US" smtClean="0"/>
+              <a:rPr lang="en-US"/>
               <a:t>Fifth level</a:t>
             </a:r>
-            <a:endParaRPr lang="en-US"/>
           </a:p>
         </p:txBody>
       </p:sp>
@@ -1301,38 +1306,37 @@
           <a:p>
             <a:pPr lvl="0"/>
             <a:r>
-              <a:rPr lang="en-US" smtClean="0"/>
+              <a:rPr lang="en-US"/>
               <a:t>Click to edit Master text styles</a:t>
             </a:r>
           </a:p>
           <a:p>
             <a:pPr lvl="1"/>
             <a:r>
-              <a:rPr lang="en-US" smtClean="0"/>
+              <a:rPr lang="en-US"/>
               <a:t>Second level</a:t>
             </a:r>
           </a:p>
           <a:p>
             <a:pPr lvl="2"/>
             <a:r>
-              <a:rPr lang="en-US" smtClean="0"/>
+              <a:rPr lang="en-US"/>
               <a:t>Third level</a:t>
             </a:r>
           </a:p>
           <a:p>
             <a:pPr lvl="3"/>
             <a:r>
-              <a:rPr lang="en-US" smtClean="0"/>
+              <a:rPr lang="en-US"/>
               <a:t>Fourth level</a:t>
             </a:r>
           </a:p>
           <a:p>
             <a:pPr lvl="4"/>
             <a:r>
-              <a:rPr lang="en-US" smtClean="0"/>
+              <a:rPr lang="en-US"/>
               <a:t>Fifth level</a:t>
             </a:r>
-            <a:endParaRPr lang="en-US"/>
           </a:p>
         </p:txBody>
       </p:sp>
@@ -1353,7 +1357,7 @@
           <a:p>
             <a:fld id="{5BCAD085-E8A6-8845-BD4E-CB4CCA059FC4}" type="datetimeFigureOut">
               <a:rPr lang="en-US" smtClean="0"/>
-              <a:t>1/27/13</a:t>
+              <a:t>10/16/2026</a:t>
             </a:fld>
             <a:endParaRPr lang="en-US"/>
           </a:p>
@@ -1451,10 +1455,9 @@
           </a:lstStyle>
           <a:p>
             <a:r>
-              <a:rPr lang="en-US" smtClean="0"/>
+              <a:rPr lang="en-US"/>
               <a:t>Click to edit Master title style</a:t>
             </a:r>
-            <a:endParaRPr lang="en-US"/>
           </a:p>
         </p:txBody>
       </p:sp>
@@ -1517,7 +1520,7 @@
           <a:p>
             <a:pPr lvl="0"/>
             <a:r>
-              <a:rPr lang="en-US" smtClean="0"/>
+              <a:rPr lang="en-US"/>
               <a:t>Click to edit Master text styles</a:t>
             </a:r>
           </a:p>
@@ -1573,38 +1576,37 @@
           <a:p>
             <a:pPr lvl="0"/>
             <a:r>
-              <a:rPr lang="en-US" smtClean="0"/>
+              <a:rPr lang="en-US"/>
               <a:t>Click to edit Master text styles</a:t>
             </a:r>
           </a:p>
           <a:p>
             <a:pPr lvl="1"/>
             <a:r>
-              <a:rPr lang="en-US" smtClean="0"/>
+              <a:rPr lang="en-US"/>
               <a:t>Second level</a:t>
             </a:r>
           </a:p>
           <a:p>
             <a:pPr lvl="2"/>
             <a:r>
-              <a:rPr lang="en-US" smtClean="0"/>
+              <a:rPr lang="en-US"/>
               <a:t>Third level</a:t>
             </a:r>
           </a:p>
           <a:p>
             <a:pPr lvl="3"/>
             <a:r>
-              <a:rPr lang="en-US" smtClean="0"/>
+              <a:rPr lang="en-US"/>
               <a:t>Fourth level</a:t>
             </a:r>
           </a:p>
           <a:p>
             <a:pPr lvl="4"/>
             <a:r>
-              <a:rPr lang="en-US" smtClean="0"/>
+              <a:rPr lang="en-US"/>
               <a:t>Fifth level</a:t>
             </a:r>
-            <a:endParaRPr lang="en-US"/>
           </a:p>
         </p:txBody>
       </p:sp>
@@ -1667,7 +1669,7 @@
           <a:p>
             <a:pPr lvl="0"/>
             <a:r>
-              <a:rPr lang="en-US" smtClean="0"/>
+              <a:rPr lang="en-US"/>
               <a:t>Click to edit Master text styles</a:t>
             </a:r>
           </a:p>
@@ -1723,38 +1725,37 @@
           <a:p>
             <a:pPr lvl="0"/>
             <a:r>
-              <a:rPr lang="en-US" smtClean="0"/>
+              <a:rPr lang="en-US"/>
               <a:t>Click to edit Master text styles</a:t>
             </a:r>
           </a:p>
           <a:p>
             <a:pPr lvl="1"/>
             <a:r>
-              <a:rPr lang="en-US" smtClean="0"/>
+              <a:rPr lang="en-US"/>
               <a:t>Second level</a:t>
             </a:r>
           </a:p>
           <a:p>
             <a:pPr lvl="2"/>
             <a:r>
-              <a:rPr lang="en-US" smtClean="0"/>
+              <a:rPr lang="en-US"/>
               <a:t>Third level</a:t>
             </a:r>
           </a:p>
           <a:p>
             <a:pPr lvl="3"/>
             <a:r>
-              <a:rPr lang="en-US" smtClean="0"/>
+              <a:rPr lang="en-US"/>
               <a:t>Fourth level</a:t>
             </a:r>
           </a:p>
           <a:p>
             <a:pPr lvl="4"/>
             <a:r>
-              <a:rPr lang="en-US" smtClean="0"/>
+              <a:rPr lang="en-US"/>
               <a:t>Fifth level</a:t>
             </a:r>
-            <a:endParaRPr lang="en-US"/>
           </a:p>
         </p:txBody>
       </p:sp>
@@ -1775,7 +1776,7 @@
           <a:p>
             <a:fld id="{5BCAD085-E8A6-8845-BD4E-CB4CCA059FC4}" type="datetimeFigureOut">
               <a:rPr lang="en-US" smtClean="0"/>
-              <a:t>1/27/13</a:t>
+              <a:t>10/16/2026</a:t>
             </a:fld>
             <a:endParaRPr lang="en-US"/>
           </a:p>
@@ -1869,10 +1870,9 @@
           <a:lstStyle/>
           <a:p>
             <a:r>
-              <a:rPr lang="en-US" smtClean="0"/>
+              <a:rPr lang="en-US"/>
               <a:t>Click to edit Master title style</a:t>
             </a:r>
-            <a:endParaRPr lang="en-US"/>
           </a:p>
         </p:txBody>
       </p:sp>
@@ -1893,7 +1893,7 @@
           <a:p>
             <a:fld id="{5BCAD085-E8A6-8845-BD4E-CB4CCA059FC4}" type="datetimeFigureOut">
               <a:rPr lang="en-US" smtClean="0"/>
-              <a:t>1/27/13</a:t>
+              <a:t>10/16/2026</a:t>
             </a:fld>
             <a:endParaRPr lang="en-US"/>
           </a:p>
@@ -1988,7 +1988,7 @@
           <a:p>
             <a:fld id="{5BCAD085-E8A6-8845-BD4E-CB4CCA059FC4}" type="datetimeFigureOut">
               <a:rPr lang="en-US" smtClean="0"/>
-              <a:t>1/27/13</a:t>
+              <a:t>10/16/2026</a:t>
             </a:fld>
             <a:endParaRPr lang="en-US"/>
           </a:p>
@@ -2091,10 +2091,9 @@
           </a:lstStyle>
           <a:p>
             <a:r>
-              <a:rPr lang="en-US" smtClean="0"/>
+              <a:rPr lang="en-US"/>
               <a:t>Click to edit Master title style</a:t>
             </a:r>
-            <a:endParaRPr lang="en-US"/>
           </a:p>
         </p:txBody>
       </p:sp>
@@ -2148,38 +2147,37 @@
           <a:p>
             <a:pPr lvl="0"/>
             <a:r>
-              <a:rPr lang="en-US" smtClean="0"/>
+              <a:rPr lang="en-US"/>
               <a:t>Click to edit Master text styles</a:t>
             </a:r>
           </a:p>
           <a:p>
             <a:pPr lvl="1"/>
             <a:r>
-              <a:rPr lang="en-US" smtClean="0"/>
+              <a:rPr lang="en-US"/>
               <a:t>Second level</a:t>
             </a:r>
           </a:p>
           <a:p>
             <a:pPr lvl="2"/>
             <a:r>
-              <a:rPr lang="en-US" smtClean="0"/>
+              <a:rPr lang="en-US"/>
               <a:t>Third level</a:t>
             </a:r>
           </a:p>
           <a:p>
             <a:pPr lvl="3"/>
             <a:r>
-              <a:rPr lang="en-US" smtClean="0"/>
+              <a:rPr lang="en-US"/>
               <a:t>Fourth level</a:t>
             </a:r>
           </a:p>
           <a:p>
             <a:pPr lvl="4"/>
             <a:r>
-              <a:rPr lang="en-US" smtClean="0"/>
+              <a:rPr lang="en-US"/>
               <a:t>Fifth level</a:t>
             </a:r>
-            <a:endParaRPr lang="en-US"/>
           </a:p>
         </p:txBody>
       </p:sp>
@@ -2242,7 +2240,7 @@
           <a:p>
             <a:pPr lvl="0"/>
             <a:r>
-              <a:rPr lang="en-US" smtClean="0"/>
+              <a:rPr lang="en-US"/>
               <a:t>Click to edit Master text styles</a:t>
             </a:r>
           </a:p>
@@ -2265,7 +2263,7 @@
           <a:p>
             <a:fld id="{5BCAD085-E8A6-8845-BD4E-CB4CCA059FC4}" type="datetimeFigureOut">
               <a:rPr lang="en-US" smtClean="0"/>
-              <a:t>1/27/13</a:t>
+              <a:t>10/16/2026</a:t>
             </a:fld>
             <a:endParaRPr lang="en-US"/>
           </a:p>
@@ -2368,10 +2366,9 @@
           </a:lstStyle>
           <a:p>
             <a:r>
-              <a:rPr lang="en-US" smtClean="0"/>
+              <a:rPr lang="en-US"/>
               <a:t>Click to edit Master title style</a:t>
             </a:r>
-            <a:endParaRPr lang="en-US"/>
           </a:p>
         </p:txBody>
       </p:sp>
@@ -2495,7 +2492,7 @@
           <a:p>
             <a:pPr lvl="0"/>
             <a:r>
-              <a:rPr lang="en-US" smtClean="0"/>
+              <a:rPr lang="en-US"/>
               <a:t>Click to edit Master text styles</a:t>
             </a:r>
           </a:p>
@@ -2518,7 +2515,7 @@
           <a:p>
             <a:fld id="{5BCAD085-E8A6-8845-BD4E-CB4CCA059FC4}" type="datetimeFigureOut">
               <a:rPr lang="en-US" smtClean="0"/>
-              <a:t>1/27/13</a:t>
+              <a:t>10/16/2026</a:t>
             </a:fld>
             <a:endParaRPr lang="en-US"/>
           </a:p>
@@ -2627,10 +2624,9 @@
           <a:lstStyle/>
           <a:p>
             <a:r>
-              <a:rPr lang="en-US" smtClean="0"/>
+              <a:rPr lang="en-US"/>
               <a:t>Click to edit Master title style</a:t>
             </a:r>
-            <a:endParaRPr lang="en-US"/>
           </a:p>
         </p:txBody>
       </p:sp>
@@ -2661,38 +2657,37 @@
           <a:p>
             <a:pPr lvl="0"/>
             <a:r>
-              <a:rPr lang="en-US" smtClean="0"/>
+              <a:rPr lang="en-US"/>
               <a:t>Click to edit Master text styles</a:t>
             </a:r>
           </a:p>
           <a:p>
             <a:pPr lvl="1"/>
             <a:r>
-              <a:rPr lang="en-US" smtClean="0"/>
+              <a:rPr lang="en-US"/>
               <a:t>Second level</a:t>
             </a:r>
           </a:p>
           <a:p>
             <a:pPr lvl="2"/>
             <a:r>
-              <a:rPr lang="en-US" smtClean="0"/>
+              <a:rPr lang="en-US"/>
               <a:t>Third level</a:t>
             </a:r>
           </a:p>
           <a:p>
             <a:pPr lvl="3"/>
             <a:r>
-              <a:rPr lang="en-US" smtClean="0"/>
+              <a:rPr lang="en-US"/>
               <a:t>Fourth level</a:t>
             </a:r>
           </a:p>
           <a:p>
             <a:pPr lvl="4"/>
             <a:r>
-              <a:rPr lang="en-US" smtClean="0"/>
+              <a:rPr lang="en-US"/>
               <a:t>Fifth level</a:t>
             </a:r>
-            <a:endParaRPr lang="en-US"/>
           </a:p>
         </p:txBody>
       </p:sp>
@@ -2731,7 +2726,7 @@
           <a:p>
             <a:fld id="{5BCAD085-E8A6-8845-BD4E-CB4CCA059FC4}" type="datetimeFigureOut">
               <a:rPr lang="en-US" smtClean="0"/>
-              <a:t>1/27/13</a:t>
+              <a:t>10/16/2026</a:t>
             </a:fld>
             <a:endParaRPr lang="en-US"/>
           </a:p>
@@ -3090,7 +3085,7 @@
 </file>
 
 <file path=ppt/slides/slide1.xml><?xml version="1.0" encoding="utf-8"?>
-<p:sld xmlns:a="http://schemas.openxmlformats.org/drawingml/2006/main" xmlns:p="http://schemas.openxmlformats.org/presentationml/2006/main" xmlns:r="http://schemas.openxmlformats.org/officeDocument/2006/relationships">
+<p:sld xmlns:a="http://schemas.openxmlformats.org/drawingml/2006/main" xmlns:r="http://schemas.openxmlformats.org/officeDocument/2006/relationships" xmlns:p="http://schemas.openxmlformats.org/presentationml/2006/main">
   <p:cSld>
     <p:spTree>
       <p:nvGrpSpPr>
@@ -3098,7 +3093,14 @@
         <p:cNvGrpSpPr/>
         <p:nvPr/>
       </p:nvGrpSpPr>
-      <p:grpSpPr/>
+      <p:grpSpPr>
+        <a:xfrm>
+          <a:off x="0" y="0"/>
+          <a:ext cx="0" cy="0"/>
+          <a:chOff x="0" y="0"/>
+          <a:chExt cx="0" cy="0"/>
+        </a:xfrm>
+      </p:grpSpPr>
       <p:sp>
         <p:nvSpPr>
           <p:cNvPr id="2" name="Rectangle 1"/>
@@ -3139,6 +3141,7 @@
           <a:lstStyle/>
           <a:p>
             <a:pPr algn="ctr"/>
+            <a:endParaRPr/>
           </a:p>
         </p:txBody>
       </p:sp>
@@ -3182,6 +3185,7 @@
           <a:lstStyle/>
           <a:p>
             <a:pPr algn="ctr"/>
+            <a:endParaRPr/>
           </a:p>
         </p:txBody>
       </p:sp>
@@ -3311,6 +3315,7 @@
           <a:lstStyle/>
           <a:p>
             <a:pPr algn="ctr"/>
+            <a:endParaRPr/>
           </a:p>
         </p:txBody>
       </p:sp>
@@ -3323,7 +3328,7 @@
         <p:spPr>
           <a:xfrm>
             <a:off x="1005840" y="5596128"/>
-            <a:ext cx="10149840" cy="548640"/>
+            <a:ext cx="8018926" cy="292388"/>
           </a:xfrm>
           <a:prstGeom prst="rect">
             <a:avLst/>
@@ -3345,7 +3350,47 @@
               </a:defRPr>
             </a:pPr>
             <a:r>
-              <a:t>Presenter: Gilbert Inkamanyire  |  Project: eWitnessVault  |  GitHub: gilbertinkamanyire/Hackafest-  |  Live Demo Ready</a:t>
+              <a:rPr dirty="0"/>
+              <a:t>Presenter</a:t>
+            </a:r>
+            <a:r>
+              <a:t>: </a:t>
+            </a:r>
+            <a:r>
+              <a:rPr lang="en-US"/>
+              <a:t>The Vault </a:t>
+            </a:r>
+            <a:r>
+              <a:rPr lang="en-US" dirty="0"/>
+              <a:t>Team</a:t>
+            </a:r>
+            <a:r>
+              <a:rPr dirty="0"/>
+              <a:t>|  Project: </a:t>
+            </a:r>
+            <a:r>
+              <a:rPr dirty="0" err="1"/>
+              <a:t>eWitnessVault</a:t>
+            </a:r>
+            <a:r>
+              <a:rPr dirty="0"/>
+              <a:t>  |  GitHub: </a:t>
+            </a:r>
+            <a:r>
+              <a:rPr dirty="0" err="1"/>
+              <a:t>gilbertinkamanyire</a:t>
+            </a:r>
+            <a:r>
+              <a:rPr dirty="0"/>
+              <a:t>/</a:t>
+            </a:r>
+            <a:r>
+              <a:rPr dirty="0" err="1"/>
+              <a:t>Hackafest</a:t>
+            </a:r>
+            <a:r>
+              <a:rPr dirty="0"/>
+              <a:t>-  |  Live Demo Ready</a:t>
             </a:r>
           </a:p>
         </p:txBody>
@@ -3359,7 +3404,7 @@
 </file>
 
 <file path=ppt/slides/slide10.xml><?xml version="1.0" encoding="utf-8"?>
-<p:sld xmlns:a="http://schemas.openxmlformats.org/drawingml/2006/main" xmlns:p="http://schemas.openxmlformats.org/presentationml/2006/main" xmlns:r="http://schemas.openxmlformats.org/officeDocument/2006/relationships">
+<p:sld xmlns:a="http://schemas.openxmlformats.org/drawingml/2006/main" xmlns:r="http://schemas.openxmlformats.org/officeDocument/2006/relationships" xmlns:p="http://schemas.openxmlformats.org/presentationml/2006/main">
   <p:cSld>
     <p:spTree>
       <p:nvGrpSpPr>
@@ -3367,7 +3412,14 @@
         <p:cNvGrpSpPr/>
         <p:nvPr/>
       </p:nvGrpSpPr>
-      <p:grpSpPr/>
+      <p:grpSpPr>
+        <a:xfrm>
+          <a:off x="0" y="0"/>
+          <a:ext cx="0" cy="0"/>
+          <a:chOff x="0" y="0"/>
+          <a:chExt cx="0" cy="0"/>
+        </a:xfrm>
+      </p:grpSpPr>
       <p:sp>
         <p:nvSpPr>
           <p:cNvPr id="2" name="Rectangle 1"/>
@@ -3408,6 +3460,7 @@
           <a:lstStyle/>
           <a:p>
             <a:pPr algn="ctr"/>
+            <a:endParaRPr/>
           </a:p>
         </p:txBody>
       </p:sp>
@@ -3561,6 +3614,7 @@
           <a:lstStyle/>
           <a:p>
             <a:pPr algn="ctr"/>
+            <a:endParaRPr/>
           </a:p>
         </p:txBody>
       </p:sp>
@@ -3686,6 +3740,7 @@
           <a:lstStyle/>
           <a:p>
             <a:pPr algn="ctr"/>
+            <a:endParaRPr/>
           </a:p>
         </p:txBody>
       </p:sp>
@@ -3811,6 +3866,7 @@
           <a:lstStyle/>
           <a:p>
             <a:pPr algn="ctr"/>
+            <a:endParaRPr/>
           </a:p>
         </p:txBody>
       </p:sp>
@@ -3936,6 +3992,7 @@
           <a:lstStyle/>
           <a:p>
             <a:pPr algn="ctr"/>
+            <a:endParaRPr/>
           </a:p>
         </p:txBody>
       </p:sp>
@@ -4028,7 +4085,7 @@
 </file>
 
 <file path=ppt/slides/slide11.xml><?xml version="1.0" encoding="utf-8"?>
-<p:sld xmlns:a="http://schemas.openxmlformats.org/drawingml/2006/main" xmlns:p="http://schemas.openxmlformats.org/presentationml/2006/main" xmlns:r="http://schemas.openxmlformats.org/officeDocument/2006/relationships">
+<p:sld xmlns:a="http://schemas.openxmlformats.org/drawingml/2006/main" xmlns:r="http://schemas.openxmlformats.org/officeDocument/2006/relationships" xmlns:p="http://schemas.openxmlformats.org/presentationml/2006/main">
   <p:cSld>
     <p:spTree>
       <p:nvGrpSpPr>
@@ -4036,7 +4093,14 @@
         <p:cNvGrpSpPr/>
         <p:nvPr/>
       </p:nvGrpSpPr>
-      <p:grpSpPr/>
+      <p:grpSpPr>
+        <a:xfrm>
+          <a:off x="0" y="0"/>
+          <a:ext cx="0" cy="0"/>
+          <a:chOff x="0" y="0"/>
+          <a:chExt cx="0" cy="0"/>
+        </a:xfrm>
+      </p:grpSpPr>
       <p:sp>
         <p:nvSpPr>
           <p:cNvPr id="2" name="Rectangle 1"/>
@@ -4077,6 +4141,7 @@
           <a:lstStyle/>
           <a:p>
             <a:pPr algn="ctr"/>
+            <a:endParaRPr/>
           </a:p>
         </p:txBody>
       </p:sp>
@@ -4230,6 +4295,7 @@
           <a:lstStyle/>
           <a:p>
             <a:pPr algn="ctr"/>
+            <a:endParaRPr/>
           </a:p>
         </p:txBody>
       </p:sp>
@@ -4343,6 +4409,7 @@
           <a:lstStyle/>
           <a:p>
             <a:pPr algn="ctr"/>
+            <a:endParaRPr/>
           </a:p>
         </p:txBody>
       </p:sp>
@@ -4456,6 +4523,7 @@
           <a:lstStyle/>
           <a:p>
             <a:pPr algn="ctr"/>
+            <a:endParaRPr/>
           </a:p>
         </p:txBody>
       </p:sp>
@@ -4569,6 +4637,7 @@
           <a:lstStyle/>
           <a:p>
             <a:pPr algn="ctr"/>
+            <a:endParaRPr/>
           </a:p>
         </p:txBody>
       </p:sp>
@@ -4649,7 +4718,7 @@
 </file>
 
 <file path=ppt/slides/slide12.xml><?xml version="1.0" encoding="utf-8"?>
-<p:sld xmlns:a="http://schemas.openxmlformats.org/drawingml/2006/main" xmlns:p="http://schemas.openxmlformats.org/presentationml/2006/main" xmlns:r="http://schemas.openxmlformats.org/officeDocument/2006/relationships">
+<p:sld xmlns:a="http://schemas.openxmlformats.org/drawingml/2006/main" xmlns:r="http://schemas.openxmlformats.org/officeDocument/2006/relationships" xmlns:p="http://schemas.openxmlformats.org/presentationml/2006/main">
   <p:cSld>
     <p:spTree>
       <p:nvGrpSpPr>
@@ -4657,7 +4726,14 @@
         <p:cNvGrpSpPr/>
         <p:nvPr/>
       </p:nvGrpSpPr>
-      <p:grpSpPr/>
+      <p:grpSpPr>
+        <a:xfrm>
+          <a:off x="0" y="0"/>
+          <a:ext cx="0" cy="0"/>
+          <a:chOff x="0" y="0"/>
+          <a:chExt cx="0" cy="0"/>
+        </a:xfrm>
+      </p:grpSpPr>
       <p:sp>
         <p:nvSpPr>
           <p:cNvPr id="2" name="Rectangle 1"/>
@@ -4698,6 +4774,7 @@
           <a:lstStyle/>
           <a:p>
             <a:pPr algn="ctr"/>
+            <a:endParaRPr/>
           </a:p>
         </p:txBody>
       </p:sp>
@@ -4743,6 +4820,7 @@
           <a:lstStyle/>
           <a:p>
             <a:pPr algn="ctr"/>
+            <a:endParaRPr/>
           </a:p>
         </p:txBody>
       </p:sp>
@@ -4871,7 +4949,7 @@
 </file>
 
 <file path=ppt/slides/slide2.xml><?xml version="1.0" encoding="utf-8"?>
-<p:sld xmlns:a="http://schemas.openxmlformats.org/drawingml/2006/main" xmlns:p="http://schemas.openxmlformats.org/presentationml/2006/main" xmlns:r="http://schemas.openxmlformats.org/officeDocument/2006/relationships">
+<p:sld xmlns:a="http://schemas.openxmlformats.org/drawingml/2006/main" xmlns:r="http://schemas.openxmlformats.org/officeDocument/2006/relationships" xmlns:p="http://schemas.openxmlformats.org/presentationml/2006/main">
   <p:cSld>
     <p:spTree>
       <p:nvGrpSpPr>
@@ -4879,7 +4957,14 @@
         <p:cNvGrpSpPr/>
         <p:nvPr/>
       </p:nvGrpSpPr>
-      <p:grpSpPr/>
+      <p:grpSpPr>
+        <a:xfrm>
+          <a:off x="0" y="0"/>
+          <a:ext cx="0" cy="0"/>
+          <a:chOff x="0" y="0"/>
+          <a:chExt cx="0" cy="0"/>
+        </a:xfrm>
+      </p:grpSpPr>
       <p:sp>
         <p:nvSpPr>
           <p:cNvPr id="2" name="Rectangle 1"/>
@@ -4920,6 +5005,7 @@
           <a:lstStyle/>
           <a:p>
             <a:pPr algn="ctr"/>
+            <a:endParaRPr/>
           </a:p>
         </p:txBody>
       </p:sp>
@@ -5073,6 +5159,7 @@
           <a:lstStyle/>
           <a:p>
             <a:pPr algn="ctr"/>
+            <a:endParaRPr/>
           </a:p>
         </p:txBody>
       </p:sp>
@@ -5219,6 +5306,7 @@
           <a:lstStyle/>
           <a:p>
             <a:pPr algn="ctr"/>
+            <a:endParaRPr/>
           </a:p>
         </p:txBody>
       </p:sp>
@@ -5365,6 +5453,7 @@
           <a:lstStyle/>
           <a:p>
             <a:pPr algn="ctr"/>
+            <a:endParaRPr/>
           </a:p>
         </p:txBody>
       </p:sp>
@@ -5478,7 +5567,7 @@
 </file>
 
 <file path=ppt/slides/slide3.xml><?xml version="1.0" encoding="utf-8"?>
-<p:sld xmlns:a="http://schemas.openxmlformats.org/drawingml/2006/main" xmlns:p="http://schemas.openxmlformats.org/presentationml/2006/main" xmlns:r="http://schemas.openxmlformats.org/officeDocument/2006/relationships">
+<p:sld xmlns:a="http://schemas.openxmlformats.org/drawingml/2006/main" xmlns:r="http://schemas.openxmlformats.org/officeDocument/2006/relationships" xmlns:p="http://schemas.openxmlformats.org/presentationml/2006/main">
   <p:cSld>
     <p:spTree>
       <p:nvGrpSpPr>
@@ -5486,7 +5575,14 @@
         <p:cNvGrpSpPr/>
         <p:nvPr/>
       </p:nvGrpSpPr>
-      <p:grpSpPr/>
+      <p:grpSpPr>
+        <a:xfrm>
+          <a:off x="0" y="0"/>
+          <a:ext cx="0" cy="0"/>
+          <a:chOff x="0" y="0"/>
+          <a:chExt cx="0" cy="0"/>
+        </a:xfrm>
+      </p:grpSpPr>
       <p:sp>
         <p:nvSpPr>
           <p:cNvPr id="2" name="Rectangle 1"/>
@@ -5527,6 +5623,7 @@
           <a:lstStyle/>
           <a:p>
             <a:pPr algn="ctr"/>
+            <a:endParaRPr/>
           </a:p>
         </p:txBody>
       </p:sp>
@@ -5610,7 +5707,7 @@
         </p:nvSpPr>
         <p:spPr>
           <a:xfrm>
-            <a:off x="731520" y="1371600"/>
+            <a:off x="838047" y="1600200"/>
             <a:ext cx="10515600" cy="457200"/>
           </a:xfrm>
           <a:prstGeom prst="rect">
@@ -5633,7 +5730,12 @@
               </a:defRPr>
             </a:pPr>
             <a:r>
-              <a:t>eWitnessVault unifies immutable digital evidence sealing with Google Gemma's open-weights intelligence.</a:t>
+              <a:rPr dirty="0" err="1"/>
+              <a:t>eWitnessVault</a:t>
+            </a:r>
+            <a:r>
+              <a:rPr dirty="0"/>
+              <a:t> unifies immutable digital evidence sealing with Google Gemma's open-weights intelligence.</a:t>
             </a:r>
           </a:p>
         </p:txBody>
@@ -5680,6 +5782,7 @@
           <a:lstStyle/>
           <a:p>
             <a:pPr algn="ctr"/>
+            <a:endParaRPr/>
           </a:p>
         </p:txBody>
       </p:sp>
@@ -5736,7 +5839,7 @@
               <a:spcBef>
                 <a:spcPts val="800"/>
               </a:spcBef>
-              <a:defRPr b="1" sz="1300">
+              <a:defRPr sz="1300" b="1">
                 <a:solidFill>
                   <a:srgbClr val="F59E0B"/>
                 </a:solidFill>
@@ -5759,7 +5862,7 @@
               <a:spcBef>
                 <a:spcPts val="800"/>
               </a:spcBef>
-              <a:defRPr b="1" sz="1300">
+              <a:defRPr sz="1300" b="1">
                 <a:solidFill>
                   <a:srgbClr val="F59E0B"/>
                 </a:solidFill>
@@ -5782,7 +5885,7 @@
               <a:spcBef>
                 <a:spcPts val="800"/>
               </a:spcBef>
-              <a:defRPr b="1" sz="1300">
+              <a:defRPr sz="1300" b="1">
                 <a:solidFill>
                   <a:srgbClr val="F59E0B"/>
                 </a:solidFill>
@@ -5844,6 +5947,7 @@
           <a:lstStyle/>
           <a:p>
             <a:pPr algn="ctr"/>
+            <a:endParaRPr/>
           </a:p>
         </p:txBody>
       </p:sp>
@@ -5900,7 +6004,7 @@
               <a:spcBef>
                 <a:spcPts val="800"/>
               </a:spcBef>
-              <a:defRPr b="1" sz="1300">
+              <a:defRPr sz="1300" b="1">
                 <a:solidFill>
                   <a:srgbClr val="A855F7"/>
                 </a:solidFill>
@@ -5923,7 +6027,7 @@
               <a:spcBef>
                 <a:spcPts val="800"/>
               </a:spcBef>
-              <a:defRPr b="1" sz="1300">
+              <a:defRPr sz="1300" b="1">
                 <a:solidFill>
                   <a:srgbClr val="A855F7"/>
                 </a:solidFill>
@@ -5946,7 +6050,7 @@
               <a:spcBef>
                 <a:spcPts val="800"/>
               </a:spcBef>
-              <a:defRPr b="1" sz="1300">
+              <a:defRPr sz="1300" b="1">
                 <a:solidFill>
                   <a:srgbClr val="A855F7"/>
                 </a:solidFill>
@@ -5975,7 +6079,7 @@
 </file>
 
 <file path=ppt/slides/slide4.xml><?xml version="1.0" encoding="utf-8"?>
-<p:sld xmlns:a="http://schemas.openxmlformats.org/drawingml/2006/main" xmlns:p="http://schemas.openxmlformats.org/presentationml/2006/main" xmlns:r="http://schemas.openxmlformats.org/officeDocument/2006/relationships">
+<p:sld xmlns:a="http://schemas.openxmlformats.org/drawingml/2006/main" xmlns:r="http://schemas.openxmlformats.org/officeDocument/2006/relationships" xmlns:p="http://schemas.openxmlformats.org/presentationml/2006/main">
   <p:cSld>
     <p:spTree>
       <p:nvGrpSpPr>
@@ -5983,7 +6087,14 @@
         <p:cNvGrpSpPr/>
         <p:nvPr/>
       </p:nvGrpSpPr>
-      <p:grpSpPr/>
+      <p:grpSpPr>
+        <a:xfrm>
+          <a:off x="0" y="0"/>
+          <a:ext cx="0" cy="0"/>
+          <a:chOff x="0" y="0"/>
+          <a:chExt cx="0" cy="0"/>
+        </a:xfrm>
+      </p:grpSpPr>
       <p:sp>
         <p:nvSpPr>
           <p:cNvPr id="2" name="Rectangle 1"/>
@@ -6024,6 +6135,7 @@
           <a:lstStyle/>
           <a:p>
             <a:pPr algn="ctr"/>
+            <a:endParaRPr/>
           </a:p>
         </p:txBody>
       </p:sp>
@@ -6177,6 +6289,7 @@
           <a:lstStyle/>
           <a:p>
             <a:pPr algn="ctr"/>
+            <a:endParaRPr/>
           </a:p>
         </p:txBody>
       </p:sp>
@@ -6356,6 +6469,7 @@
           <a:lstStyle/>
           <a:p>
             <a:pPr algn="ctr"/>
+            <a:endParaRPr/>
           </a:p>
         </p:txBody>
       </p:sp>
@@ -6535,6 +6649,7 @@
           <a:lstStyle/>
           <a:p>
             <a:pPr algn="ctr"/>
+            <a:endParaRPr/>
           </a:p>
         </p:txBody>
       </p:sp>
@@ -6714,6 +6829,7 @@
           <a:lstStyle/>
           <a:p>
             <a:pPr algn="ctr"/>
+            <a:endParaRPr/>
           </a:p>
         </p:txBody>
       </p:sp>
@@ -6860,7 +6976,7 @@
 </file>
 
 <file path=ppt/slides/slide5.xml><?xml version="1.0" encoding="utf-8"?>
-<p:sld xmlns:a="http://schemas.openxmlformats.org/drawingml/2006/main" xmlns:p="http://schemas.openxmlformats.org/presentationml/2006/main" xmlns:r="http://schemas.openxmlformats.org/officeDocument/2006/relationships">
+<p:sld xmlns:a="http://schemas.openxmlformats.org/drawingml/2006/main" xmlns:r="http://schemas.openxmlformats.org/officeDocument/2006/relationships" xmlns:p="http://schemas.openxmlformats.org/presentationml/2006/main">
   <p:cSld>
     <p:spTree>
       <p:nvGrpSpPr>
@@ -6868,7 +6984,14 @@
         <p:cNvGrpSpPr/>
         <p:nvPr/>
       </p:nvGrpSpPr>
-      <p:grpSpPr/>
+      <p:grpSpPr>
+        <a:xfrm>
+          <a:off x="0" y="0"/>
+          <a:ext cx="0" cy="0"/>
+          <a:chOff x="0" y="0"/>
+          <a:chExt cx="0" cy="0"/>
+        </a:xfrm>
+      </p:grpSpPr>
       <p:sp>
         <p:nvSpPr>
           <p:cNvPr id="2" name="Rectangle 1"/>
@@ -6909,6 +7032,7 @@
           <a:lstStyle/>
           <a:p>
             <a:pPr algn="ctr"/>
+            <a:endParaRPr/>
           </a:p>
         </p:txBody>
       </p:sp>
@@ -7062,6 +7186,7 @@
           <a:lstStyle/>
           <a:p>
             <a:pPr algn="ctr"/>
+            <a:endParaRPr/>
           </a:p>
         </p:txBody>
       </p:sp>
@@ -7175,6 +7300,7 @@
           <a:lstStyle/>
           <a:p>
             <a:pPr algn="ctr"/>
+            <a:endParaRPr/>
           </a:p>
         </p:txBody>
       </p:sp>
@@ -7288,6 +7414,7 @@
           <a:lstStyle/>
           <a:p>
             <a:pPr algn="ctr"/>
+            <a:endParaRPr/>
           </a:p>
         </p:txBody>
       </p:sp>
@@ -7401,6 +7528,7 @@
           <a:lstStyle/>
           <a:p>
             <a:pPr algn="ctr"/>
+            <a:endParaRPr/>
           </a:p>
         </p:txBody>
       </p:sp>
@@ -7481,7 +7609,7 @@
 </file>
 
 <file path=ppt/slides/slide6.xml><?xml version="1.0" encoding="utf-8"?>
-<p:sld xmlns:a="http://schemas.openxmlformats.org/drawingml/2006/main" xmlns:p="http://schemas.openxmlformats.org/presentationml/2006/main" xmlns:r="http://schemas.openxmlformats.org/officeDocument/2006/relationships">
+<p:sld xmlns:a="http://schemas.openxmlformats.org/drawingml/2006/main" xmlns:r="http://schemas.openxmlformats.org/officeDocument/2006/relationships" xmlns:p="http://schemas.openxmlformats.org/presentationml/2006/main">
   <p:cSld>
     <p:spTree>
       <p:nvGrpSpPr>
@@ -7489,7 +7617,14 @@
         <p:cNvGrpSpPr/>
         <p:nvPr/>
       </p:nvGrpSpPr>
-      <p:grpSpPr/>
+      <p:grpSpPr>
+        <a:xfrm>
+          <a:off x="0" y="0"/>
+          <a:ext cx="0" cy="0"/>
+          <a:chOff x="0" y="0"/>
+          <a:chExt cx="0" cy="0"/>
+        </a:xfrm>
+      </p:grpSpPr>
       <p:sp>
         <p:nvSpPr>
           <p:cNvPr id="2" name="Rectangle 1"/>
@@ -7530,6 +7665,7 @@
           <a:lstStyle/>
           <a:p>
             <a:pPr algn="ctr"/>
+            <a:endParaRPr/>
           </a:p>
         </p:txBody>
       </p:sp>
@@ -7683,6 +7819,7 @@
           <a:lstStyle/>
           <a:p>
             <a:pPr algn="ctr"/>
+            <a:endParaRPr/>
           </a:p>
         </p:txBody>
       </p:sp>
@@ -7805,6 +7942,7 @@
           <a:lstStyle/>
           <a:p>
             <a:pPr algn="ctr"/>
+            <a:endParaRPr/>
           </a:p>
         </p:txBody>
       </p:sp>
@@ -7927,6 +8065,7 @@
           <a:lstStyle/>
           <a:p>
             <a:pPr algn="ctr"/>
+            <a:endParaRPr/>
           </a:p>
         </p:txBody>
       </p:sp>
@@ -8049,6 +8188,7 @@
           <a:lstStyle/>
           <a:p>
             <a:pPr algn="ctr"/>
+            <a:endParaRPr/>
           </a:p>
         </p:txBody>
       </p:sp>
@@ -8138,7 +8278,7 @@
 </file>
 
 <file path=ppt/slides/slide7.xml><?xml version="1.0" encoding="utf-8"?>
-<p:sld xmlns:a="http://schemas.openxmlformats.org/drawingml/2006/main" xmlns:p="http://schemas.openxmlformats.org/presentationml/2006/main" xmlns:r="http://schemas.openxmlformats.org/officeDocument/2006/relationships">
+<p:sld xmlns:a="http://schemas.openxmlformats.org/drawingml/2006/main" xmlns:r="http://schemas.openxmlformats.org/officeDocument/2006/relationships" xmlns:p="http://schemas.openxmlformats.org/presentationml/2006/main">
   <p:cSld>
     <p:spTree>
       <p:nvGrpSpPr>
@@ -8146,7 +8286,14 @@
         <p:cNvGrpSpPr/>
         <p:nvPr/>
       </p:nvGrpSpPr>
-      <p:grpSpPr/>
+      <p:grpSpPr>
+        <a:xfrm>
+          <a:off x="0" y="0"/>
+          <a:ext cx="0" cy="0"/>
+          <a:chOff x="0" y="0"/>
+          <a:chExt cx="0" cy="0"/>
+        </a:xfrm>
+      </p:grpSpPr>
       <p:sp>
         <p:nvSpPr>
           <p:cNvPr id="2" name="Rectangle 1"/>
@@ -8187,6 +8334,7 @@
           <a:lstStyle/>
           <a:p>
             <a:pPr algn="ctr"/>
+            <a:endParaRPr/>
           </a:p>
         </p:txBody>
       </p:sp>
@@ -8270,7 +8418,7 @@
         </p:nvSpPr>
         <p:spPr>
           <a:xfrm>
-            <a:off x="731520" y="1371600"/>
+            <a:off x="715975" y="1587137"/>
             <a:ext cx="10515600" cy="457200"/>
           </a:xfrm>
           <a:prstGeom prst="rect">
@@ -8293,6 +8441,7 @@
               </a:defRPr>
             </a:pPr>
             <a:r>
+              <a:rPr dirty="0"/>
               <a:t>Demonstrating Gemma's forensic analysis on multi-exhibit criminal court docket.</a:t>
             </a:r>
           </a:p>
@@ -8340,6 +8489,7 @@
           <a:lstStyle/>
           <a:p>
             <a:pPr algn="ctr"/>
+            <a:endParaRPr/>
           </a:p>
         </p:txBody>
       </p:sp>
@@ -8510,6 +8660,7 @@
           <a:lstStyle/>
           <a:p>
             <a:pPr algn="ctr"/>
+            <a:endParaRPr/>
           </a:p>
         </p:txBody>
       </p:sp>
@@ -8566,7 +8717,7 @@
               <a:spcBef>
                 <a:spcPts val="500"/>
               </a:spcBef>
-              <a:defRPr b="1" sz="1200">
+              <a:defRPr sz="1200" b="1">
                 <a:solidFill>
                   <a:srgbClr val="A855F7"/>
                 </a:solidFill>
@@ -8589,7 +8740,7 @@
               <a:spcBef>
                 <a:spcPts val="500"/>
               </a:spcBef>
-              <a:defRPr b="1" sz="1200">
+              <a:defRPr sz="1200" b="1">
                 <a:solidFill>
                   <a:srgbClr val="A855F7"/>
                 </a:solidFill>
@@ -8612,7 +8763,7 @@
               <a:spcBef>
                 <a:spcPts val="500"/>
               </a:spcBef>
-              <a:defRPr b="1" sz="1200">
+              <a:defRPr sz="1200" b="1">
                 <a:solidFill>
                   <a:srgbClr val="A855F7"/>
                 </a:solidFill>
@@ -8635,7 +8786,7 @@
               <a:spcBef>
                 <a:spcPts val="500"/>
               </a:spcBef>
-              <a:defRPr b="1" sz="1200">
+              <a:defRPr sz="1200" b="1">
                 <a:solidFill>
                   <a:srgbClr val="A855F7"/>
                 </a:solidFill>
@@ -8664,7 +8815,7 @@
 </file>
 
 <file path=ppt/slides/slide8.xml><?xml version="1.0" encoding="utf-8"?>
-<p:sld xmlns:a="http://schemas.openxmlformats.org/drawingml/2006/main" xmlns:p="http://schemas.openxmlformats.org/presentationml/2006/main" xmlns:r="http://schemas.openxmlformats.org/officeDocument/2006/relationships">
+<p:sld xmlns:a="http://schemas.openxmlformats.org/drawingml/2006/main" xmlns:r="http://schemas.openxmlformats.org/officeDocument/2006/relationships" xmlns:p="http://schemas.openxmlformats.org/presentationml/2006/main">
   <p:cSld>
     <p:spTree>
       <p:nvGrpSpPr>
@@ -8672,7 +8823,14 @@
         <p:cNvGrpSpPr/>
         <p:nvPr/>
       </p:nvGrpSpPr>
-      <p:grpSpPr/>
+      <p:grpSpPr>
+        <a:xfrm>
+          <a:off x="0" y="0"/>
+          <a:ext cx="0" cy="0"/>
+          <a:chOff x="0" y="0"/>
+          <a:chExt cx="0" cy="0"/>
+        </a:xfrm>
+      </p:grpSpPr>
       <p:sp>
         <p:nvSpPr>
           <p:cNvPr id="2" name="Rectangle 1"/>
@@ -8713,6 +8871,7 @@
           <a:lstStyle/>
           <a:p>
             <a:pPr algn="ctr"/>
+            <a:endParaRPr/>
           </a:p>
         </p:txBody>
       </p:sp>
@@ -8843,10 +9002,34 @@
                 <a:tableStyleId>{5C22544A-7EE6-4342-B048-85BDC9FD1C3A}</a:tableStyleId>
               </a:tblPr>
               <a:tblGrid>
-                <a:gridCol w="3200400"/>
-                <a:gridCol w="2560320"/>
-                <a:gridCol w="2468880"/>
-                <a:gridCol w="2499055"/>
+                <a:gridCol w="3200400">
+                  <a:extLst>
+                    <a:ext uri="{9D8B030D-6E8A-4147-A177-3AD203B41FA5}">
+                      <a16:colId xmlns:a16="http://schemas.microsoft.com/office/drawing/2014/main" val="20000"/>
+                    </a:ext>
+                  </a:extLst>
+                </a:gridCol>
+                <a:gridCol w="2560320">
+                  <a:extLst>
+                    <a:ext uri="{9D8B030D-6E8A-4147-A177-3AD203B41FA5}">
+                      <a16:colId xmlns:a16="http://schemas.microsoft.com/office/drawing/2014/main" val="20001"/>
+                    </a:ext>
+                  </a:extLst>
+                </a:gridCol>
+                <a:gridCol w="2468880">
+                  <a:extLst>
+                    <a:ext uri="{9D8B030D-6E8A-4147-A177-3AD203B41FA5}">
+                      <a16:colId xmlns:a16="http://schemas.microsoft.com/office/drawing/2014/main" val="20002"/>
+                    </a:ext>
+                  </a:extLst>
+                </a:gridCol>
+                <a:gridCol w="2499055">
+                  <a:extLst>
+                    <a:ext uri="{9D8B030D-6E8A-4147-A177-3AD203B41FA5}">
+                      <a16:colId xmlns:a16="http://schemas.microsoft.com/office/drawing/2014/main" val="20003"/>
+                    </a:ext>
+                  </a:extLst>
+                </a:gridCol>
               </a:tblGrid>
               <a:tr h="804672">
                 <a:tc>
@@ -8855,7 +9038,7 @@
                     <a:lstStyle/>
                     <a:p>
                       <a:pPr algn="l">
-                        <a:defRPr b="1" sz="1300">
+                        <a:defRPr sz="1300" b="1">
                           <a:solidFill>
                             <a:srgbClr val="F8FAFC"/>
                           </a:solidFill>
@@ -8878,7 +9061,7 @@
                     <a:lstStyle/>
                     <a:p>
                       <a:pPr algn="ctr">
-                        <a:defRPr b="1" sz="1300">
+                        <a:defRPr sz="1300" b="1">
                           <a:solidFill>
                             <a:srgbClr val="F8FAFC"/>
                           </a:solidFill>
@@ -8901,7 +9084,7 @@
                     <a:lstStyle/>
                     <a:p>
                       <a:pPr algn="ctr">
-                        <a:defRPr b="1" sz="1300">
+                        <a:defRPr sz="1300" b="1">
                           <a:solidFill>
                             <a:srgbClr val="F8FAFC"/>
                           </a:solidFill>
@@ -8924,7 +9107,7 @@
                     <a:lstStyle/>
                     <a:p>
                       <a:pPr algn="ctr">
-                        <a:defRPr b="1" sz="1300">
+                        <a:defRPr sz="1300" b="1">
                           <a:solidFill>
                             <a:srgbClr val="F8FAFC"/>
                           </a:solidFill>
@@ -8941,6 +9124,11 @@
                     </a:solidFill>
                   </a:tcPr>
                 </a:tc>
+                <a:extLst>
+                  <a:ext uri="{0D108BD9-81ED-4DB2-BD59-A6C34878D82A}">
+                    <a16:rowId xmlns:a16="http://schemas.microsoft.com/office/drawing/2014/main" val="10000"/>
+                  </a:ext>
+                </a:extLst>
               </a:tr>
               <a:tr h="804672">
                 <a:tc>
@@ -9035,6 +9223,11 @@
                     </a:solidFill>
                   </a:tcPr>
                 </a:tc>
+                <a:extLst>
+                  <a:ext uri="{0D108BD9-81ED-4DB2-BD59-A6C34878D82A}">
+                    <a16:rowId xmlns:a16="http://schemas.microsoft.com/office/drawing/2014/main" val="10001"/>
+                  </a:ext>
+                </a:extLst>
               </a:tr>
               <a:tr h="804672">
                 <a:tc>
@@ -9129,6 +9322,11 @@
                     </a:solidFill>
                   </a:tcPr>
                 </a:tc>
+                <a:extLst>
+                  <a:ext uri="{0D108BD9-81ED-4DB2-BD59-A6C34878D82A}">
+                    <a16:rowId xmlns:a16="http://schemas.microsoft.com/office/drawing/2014/main" val="10002"/>
+                  </a:ext>
+                </a:extLst>
               </a:tr>
               <a:tr h="804672">
                 <a:tc>
@@ -9223,6 +9421,11 @@
                     </a:solidFill>
                   </a:tcPr>
                 </a:tc>
+                <a:extLst>
+                  <a:ext uri="{0D108BD9-81ED-4DB2-BD59-A6C34878D82A}">
+                    <a16:rowId xmlns:a16="http://schemas.microsoft.com/office/drawing/2014/main" val="10003"/>
+                  </a:ext>
+                </a:extLst>
               </a:tr>
               <a:tr h="804672">
                 <a:tc>
@@ -9317,6 +9520,11 @@
                     </a:solidFill>
                   </a:tcPr>
                 </a:tc>
+                <a:extLst>
+                  <a:ext uri="{0D108BD9-81ED-4DB2-BD59-A6C34878D82A}">
+                    <a16:rowId xmlns:a16="http://schemas.microsoft.com/office/drawing/2014/main" val="10004"/>
+                  </a:ext>
+                </a:extLst>
               </a:tr>
             </a:tbl>
           </a:graphicData>
@@ -9331,7 +9539,7 @@
 </file>
 
 <file path=ppt/slides/slide9.xml><?xml version="1.0" encoding="utf-8"?>
-<p:sld xmlns:a="http://schemas.openxmlformats.org/drawingml/2006/main" xmlns:p="http://schemas.openxmlformats.org/presentationml/2006/main" xmlns:r="http://schemas.openxmlformats.org/officeDocument/2006/relationships">
+<p:sld xmlns:a="http://schemas.openxmlformats.org/drawingml/2006/main" xmlns:r="http://schemas.openxmlformats.org/officeDocument/2006/relationships" xmlns:p="http://schemas.openxmlformats.org/presentationml/2006/main">
   <p:cSld>
     <p:spTree>
       <p:nvGrpSpPr>
@@ -9339,7 +9547,14 @@
         <p:cNvGrpSpPr/>
         <p:nvPr/>
       </p:nvGrpSpPr>
-      <p:grpSpPr/>
+      <p:grpSpPr>
+        <a:xfrm>
+          <a:off x="0" y="0"/>
+          <a:ext cx="0" cy="0"/>
+          <a:chOff x="0" y="0"/>
+          <a:chExt cx="0" cy="0"/>
+        </a:xfrm>
+      </p:grpSpPr>
       <p:sp>
         <p:nvSpPr>
           <p:cNvPr id="2" name="Rectangle 1"/>
@@ -9380,6 +9595,7 @@
           <a:lstStyle/>
           <a:p>
             <a:pPr algn="ctr"/>
+            <a:endParaRPr/>
           </a:p>
         </p:txBody>
       </p:sp>
@@ -9533,6 +9749,7 @@
           <a:lstStyle/>
           <a:p>
             <a:pPr algn="ctr"/>
+            <a:endParaRPr/>
           </a:p>
         </p:txBody>
       </p:sp>
@@ -9688,6 +9905,7 @@
           <a:lstStyle/>
           <a:p>
             <a:pPr algn="ctr"/>
+            <a:endParaRPr/>
           </a:p>
         </p:txBody>
       </p:sp>
@@ -9843,6 +10061,7 @@
           <a:lstStyle/>
           <a:p>
             <a:pPr algn="ctr"/>
+            <a:endParaRPr/>
           </a:p>
         </p:txBody>
       </p:sp>

</xml_diff>